<commit_message>
release: finalize EconoCausal v1.0.0 deliverables and audit trail
</commit_message>
<xml_diff>
--- a/05_Final_Deliverables/EconoCausal_Final_Presentation.pptx
+++ b/05_Final_Deliverables/EconoCausal_Final_Presentation.pptx
@@ -5326,39 +5326,39 @@
               </a:defRPr>
             </a:pPr>
             <a:r>
-              <a:t>39 Automated Tests Across 5 Test Suites — 100% Passed</a:t>
-            </a:r>
-          </a:p>
-          <a:p>
-            <a:pPr>
-              <a:spcAft>
-                <a:spcPts val="600"/>
-              </a:spcAft>
-              <a:defRPr sz="1100">
-                <a:solidFill>
-                  <a:srgbClr val="F8FAFC"/>
-                </a:solidFill>
-                <a:latin typeface="Segoe UI"/>
-              </a:defRPr>
-            </a:pPr>
-            <a:r>
-              <a:t>• 1. 02_Causal_ML/test_dml.py: 4 tests | 100% PASS (55s)</a:t>
-            </a:r>
-          </a:p>
-          <a:p>
-            <a:pPr>
-              <a:spcAft>
-                <a:spcPts val="600"/>
-              </a:spcAft>
-              <a:defRPr sz="1100">
-                <a:solidFill>
-                  <a:srgbClr val="F8FAFC"/>
-                </a:solidFill>
-                <a:latin typeface="Segoe UI"/>
-              </a:defRPr>
-            </a:pPr>
-            <a:r>
-              <a:t>•    - Verifies DML cross-fitting, LightGBM base estimators, CATE estimation bounds, and schema.</a:t>
+              <a:t>Automated Testing &amp; Governance Scorecard (66 Defined Unit Tests)</a:t>
+            </a:r>
+          </a:p>
+          <a:p>
+            <a:pPr>
+              <a:spcAft>
+                <a:spcPts val="600"/>
+              </a:spcAft>
+              <a:defRPr sz="1100">
+                <a:solidFill>
+                  <a:srgbClr val="F8FAFC"/>
+                </a:solidFill>
+                <a:latin typeface="Segoe UI"/>
+              </a:defRPr>
+            </a:pPr>
+            <a:r>
+              <a:t>• 1. 02_Causal_ML/test_dml.py: 5 Defined Tests (3 Safe Runnable + 2 Permanently Quarantined)</a:t>
+            </a:r>
+          </a:p>
+          <a:p>
+            <a:pPr>
+              <a:spcAft>
+                <a:spcPts val="600"/>
+              </a:spcAft>
+              <a:defRPr sz="1100">
+                <a:solidFill>
+                  <a:srgbClr val="F8FAFC"/>
+                </a:solidFill>
+                <a:latin typeface="Segoe UI"/>
+              </a:defRPr>
+            </a:pPr>
+            <a:r>
+              <a:t>•    - Verifies missing file handling, anti-leakage guards, and artifact immutability. Retraining tests quarantined against benchmark leakage.</a:t>
             </a:r>
           </a:p>
           <a:p>
@@ -5390,23 +5390,23 @@
               </a:defRPr>
             </a:pPr>
             <a:r>
-              <a:t>• 2. 03_Backend_Optimization/test_optimizer.py: 12 tests | 100% PASS (26s)</a:t>
-            </a:r>
-          </a:p>
-          <a:p>
-            <a:pPr>
-              <a:spcAft>
-                <a:spcPts val="600"/>
-              </a:spcAft>
-              <a:defRPr sz="1100">
-                <a:solidFill>
-                  <a:srgbClr val="F8FAFC"/>
-                </a:solidFill>
-                <a:latin typeface="Segoe UI"/>
-              </a:defRPr>
-            </a:pPr>
-            <a:r>
-              <a:t>•    - Verifies budget caps, anti-leakage guards, zero budget, mutual exclusivity, deterministic MILP vs exhaustive search parity, and solver fallback.</a:t>
+              <a:t>• 2. 03_Backend_Optimization/test_optimizer.py: 13 Tests | 100% LIVE PASS (23.8s)</a:t>
+            </a:r>
+          </a:p>
+          <a:p>
+            <a:pPr>
+              <a:spcAft>
+                <a:spcPts val="600"/>
+              </a:spcAft>
+              <a:defRPr sz="1100">
+                <a:solidFill>
+                  <a:srgbClr val="F8FAFC"/>
+                </a:solidFill>
+                <a:latin typeface="Segoe UI"/>
+              </a:defRPr>
+            </a:pPr>
+            <a:r>
+              <a:t>•    - Verifies HiGHS MILP knapsack, greedy fallback, budget monotonicity, mutual exclusivity, and zero-budget edge cases.</a:t>
             </a:r>
           </a:p>
           <a:p>
@@ -5438,23 +5438,23 @@
               </a:defRPr>
             </a:pPr>
             <a:r>
-              <a:t>• 3. 03_Backend_Optimization/test_validation.py: 5 tests | 100% PASS (5s)</a:t>
-            </a:r>
-          </a:p>
-          <a:p>
-            <a:pPr>
-              <a:spcAft>
-                <a:spcPts val="600"/>
-              </a:spcAft>
-              <a:defRPr sz="1100">
-                <a:solidFill>
-                  <a:srgbClr val="F8FAFC"/>
-                </a:solidFill>
-                <a:latin typeface="Segoe UI"/>
-              </a:defRPr>
-            </a:pPr>
-            <a:r>
-              <a:t>•    - Verifies PSM caliper match rate (&gt;95%), covariate balance (|SMD| &lt; 0.10 for all 9 features), and 4 causal refutation criteria.</a:t>
+              <a:t>• 3. 03_Backend_Optimization/test_validation.py: 14 Tests | 100% Historical Pass (Host WDAC Constrained in L8)</a:t>
+            </a:r>
+          </a:p>
+          <a:p>
+            <a:pPr>
+              <a:spcAft>
+                <a:spcPts val="600"/>
+              </a:spcAft>
+              <a:defRPr sz="1100">
+                <a:solidFill>
+                  <a:srgbClr val="F8FAFC"/>
+                </a:solidFill>
+                <a:latin typeface="Segoe UI"/>
+              </a:defRPr>
+            </a:pPr>
+            <a:r>
+              <a:t>•    - Verifies PSM caliper balance (|SMD| &lt; 0.022), 5 refutation stress tests, Rosenbaum bounds (Γ*=1.7, 2.1), and Cinelli-Hazlett RV (12.4%, 17.8%).</a:t>
             </a:r>
           </a:p>
           <a:p>
@@ -5486,23 +5486,23 @@
               </a:defRPr>
             </a:pPr>
             <a:r>
-              <a:t>• 4. 04_Frontend_Dashboard/backend/test_api.py: 17 tests | 100% PASS (7s)</a:t>
-            </a:r>
-          </a:p>
-          <a:p>
-            <a:pPr>
-              <a:spcAft>
-                <a:spcPts val="600"/>
-              </a:spcAft>
-              <a:defRPr sz="1100">
-                <a:solidFill>
-                  <a:srgbClr val="F8FAFC"/>
-                </a:solidFill>
-                <a:latin typeface="Segoe UI"/>
-              </a:defRPr>
-            </a:pPr>
-            <a:r>
-              <a:t>•    - Verifies all endpoints, schemas, pagination, filters, live simulation, Qini data, and CORS trusted origins.</a:t>
+              <a:t>• 4. 04_Frontend_Dashboard/backend/test_api.py: 34 Tests | 33 LIVE PASS, 1 Host WDAC Blocked (65.5s)</a:t>
+            </a:r>
+          </a:p>
+          <a:p>
+            <a:pPr>
+              <a:spcAft>
+                <a:spcPts val="600"/>
+              </a:spcAft>
+              <a:defRPr sz="1100">
+                <a:solidFill>
+                  <a:srgbClr val="F8FAFC"/>
+                </a:solidFill>
+                <a:latin typeface="Segoe UI"/>
+              </a:defRPr>
+            </a:pPr>
+            <a:r>
+              <a:t>•    - Verifies 11 endpoints, pagination, filters, Qini aggregations, simulation caching, CORS, and anti-leakage guards.</a:t>
             </a:r>
           </a:p>
           <a:p>
@@ -5534,7 +5534,7 @@
               </a:defRPr>
             </a:pPr>
             <a:r>
-              <a:t>• 5. 04_Frontend_Dashboard (npm run build): Production Vite Build | 100% PASS (543ms)</a:t>
+              <a:t>• 5. Technical Checks: Dataset CLI (Pass), Vite Build (Pass 2.22s), Frontend Lint (Host WDAC Blocked), Native Print (Not Verified)</a:t>
             </a:r>
           </a:p>
         </p:txBody>
@@ -6494,7 +6494,7 @@
               </a:defRPr>
             </a:pPr>
             <a:r>
-              <a:t>• Validated across 39 automated tests.</a:t>
+              <a:t>• Validated across 66 defined unit tests (64 safe runnable; 47 live passed, 17 WDAC-constrained, 2 quarantined).</a:t>
             </a:r>
           </a:p>
         </p:txBody>
@@ -6800,7 +6800,7 @@
               </a:defRPr>
             </a:pPr>
             <a:r>
-              <a:t>• 7. Validation Audit: Review Love Plot balance, 4 refutation tests, DoWhy DAG, and Drift monitoring.</a:t>
+              <a:t>• 7. Validation Audit: Review Love Plot balance, 5 refutation stress-tests, DoWhy DAG, and Drift monitoring.</a:t>
             </a:r>
           </a:p>
         </p:txBody>
@@ -6964,7 +6964,7 @@
               </a:defRPr>
             </a:pPr>
             <a:r>
-              <a:t>• A: 'We verified covariate balance across all 9 confounders (|SMD| &lt; 0.022) and passed all 4 gold-standard refutations including Placebo tests (p=0.485).'</a:t>
+              <a:t>• A: 'We verified covariate balance across all 9 confounders (|SMD| &lt; 0.022) and passed all 5 gold-standard refutations including Placebo (p=0.485) and Residual Permutation (p=0.002).'</a:t>
             </a:r>
           </a:p>
           <a:p>
@@ -7145,11 +7145,11 @@
             </a:r>
             <a:br/>
             <a:r>
-              <a:t>• Delivered complete full-stack enterprise dashboard, automated test suites (39/39 passing), and verified evaluation benchmarks.</a:t>
+              <a:t>• Delivered full-stack enterprise dashboard, comprehensive automated test suites (66 defined unit tests; 64 safe runnable; 2 quarantined), and verified benchmark diagnostics.</a:t>
             </a:r>
             <a:br/>
             <a:r>
-              <a:t>• All formal deliverables (DOCX Report, PDF Report, PPTX Deck, Excel Evaluation Workbook, Markdown Companions, and Audit Reports) generated and certified.</a:t>
+              <a:t>• All formal deliverables (DOCX Report, PDF Report, PPTX Deck, Excel Evaluation Workbook, Markdown Companions, and Audit Reports) synchronized and verified.</a:t>
             </a:r>
             <a:br/>
             <a:br/>

</xml_diff>